<commit_message>
fix(eval): update presentation.pptx fixture coverage for cross-format parity
</commit_message>
<xml_diff>
--- a/eval/fixtures/presentation.pptx
+++ b/eval/fixtures/presentation.pptx
@@ -8,6 +8,8 @@
     <p:sldId id="256" r:id="rId7"/>
     <p:sldId id="257" r:id="rId9"/>
     <p:sldId id="258" r:id="rId10"/>
+    <p:sldId id="259" r:id="rId11"/>
+    <p:sldId id="260" r:id="rId12"/>
   </p:sldIdLst>
   <p:sldSz cx="9144000" cy="6858000" type="screen4x3"/>
   <p:notesSz cx="6858000" cy="9144000"/>
@@ -575,6 +577,146 @@
           <a:p>
             <a:r>
               <a:t>Mandated under standard ISO-27001 security protocols.</a:t>
+            </a:r>
+          </a:p>
+        </p:txBody>
+      </p:sp>
+      <p:sp>
+        <p:nvSpPr>
+          <p:cNvPr id="4" name="Slide Number Placeholder 3"/>
+          <p:cNvSpPr>
+            <a:spLocks noGrp="1"/>
+          </p:cNvSpPr>
+          <p:nvPr>
+            <p:ph type="sldNum" idx="5" sz="quarter"/>
+          </p:nvPr>
+        </p:nvSpPr>
+        <p:spPr/>
+      </p:sp>
+    </p:spTree>
+  </p:cSld>
+  <p:clrMapOvr>
+    <a:masterClrMapping/>
+  </p:clrMapOvr>
+</p:notes>
+</file>
+
+<file path=ppt/notesSlides/notesSlide3.xml><?xml version="1.0" encoding="utf-8"?>
+<p:notes xmlns:a="http://schemas.openxmlformats.org/drawingml/2006/main" xmlns:p="http://schemas.openxmlformats.org/presentationml/2006/main" xmlns:r="http://schemas.openxmlformats.org/officeDocument/2006/relationships">
+  <p:cSld>
+    <p:spTree>
+      <p:nvGrpSpPr>
+        <p:cNvPr id="1" name=""/>
+        <p:cNvGrpSpPr/>
+        <p:nvPr/>
+      </p:nvGrpSpPr>
+      <p:grpSpPr>
+        <a:xfrm>
+          <a:off x="0" y="0"/>
+          <a:ext cx="0" cy="0"/>
+          <a:chOff x="0" y="0"/>
+          <a:chExt cx="0" cy="0"/>
+        </a:xfrm>
+      </p:grpSpPr>
+      <p:sp>
+        <p:nvSpPr>
+          <p:cNvPr id="2" name="Slide Image Placeholder 1"/>
+          <p:cNvSpPr>
+            <a:spLocks noGrp="1"/>
+          </p:cNvSpPr>
+          <p:nvPr>
+            <p:ph type="sldImg" idx="2"/>
+          </p:nvPr>
+        </p:nvSpPr>
+        <p:spPr/>
+      </p:sp>
+      <p:sp>
+        <p:nvSpPr>
+          <p:cNvPr id="3" name="Notes Placeholder 2"/>
+          <p:cNvSpPr>
+            <a:spLocks noGrp="1"/>
+          </p:cNvSpPr>
+          <p:nvPr>
+            <p:ph type="body" idx="3" sz="quarter"/>
+          </p:nvPr>
+        </p:nvSpPr>
+        <p:spPr/>
+        <p:txBody>
+          <a:bodyPr/>
+          <a:lstStyle/>
+          <a:p>
+            <a:r>
+              <a:t>Accrual rate 2.0 working days per month of service.</a:t>
+            </a:r>
+          </a:p>
+        </p:txBody>
+      </p:sp>
+      <p:sp>
+        <p:nvSpPr>
+          <p:cNvPr id="4" name="Slide Number Placeholder 3"/>
+          <p:cNvSpPr>
+            <a:spLocks noGrp="1"/>
+          </p:cNvSpPr>
+          <p:nvPr>
+            <p:ph type="sldNum" idx="5" sz="quarter"/>
+          </p:nvPr>
+        </p:nvSpPr>
+        <p:spPr/>
+      </p:sp>
+    </p:spTree>
+  </p:cSld>
+  <p:clrMapOvr>
+    <a:masterClrMapping/>
+  </p:clrMapOvr>
+</p:notes>
+</file>
+
+<file path=ppt/notesSlides/notesSlide4.xml><?xml version="1.0" encoding="utf-8"?>
+<p:notes xmlns:a="http://schemas.openxmlformats.org/drawingml/2006/main" xmlns:p="http://schemas.openxmlformats.org/presentationml/2006/main" xmlns:r="http://schemas.openxmlformats.org/officeDocument/2006/relationships">
+  <p:cSld>
+    <p:spTree>
+      <p:nvGrpSpPr>
+        <p:cNvPr id="1" name=""/>
+        <p:cNvGrpSpPr/>
+        <p:nvPr/>
+      </p:nvGrpSpPr>
+      <p:grpSpPr>
+        <a:xfrm>
+          <a:off x="0" y="0"/>
+          <a:ext cx="0" cy="0"/>
+          <a:chOff x="0" y="0"/>
+          <a:chExt cx="0" cy="0"/>
+        </a:xfrm>
+      </p:grpSpPr>
+      <p:sp>
+        <p:nvSpPr>
+          <p:cNvPr id="2" name="Slide Image Placeholder 1"/>
+          <p:cNvSpPr>
+            <a:spLocks noGrp="1"/>
+          </p:cNvSpPr>
+          <p:nvPr>
+            <p:ph type="sldImg" idx="2"/>
+          </p:nvPr>
+        </p:nvSpPr>
+        <p:spPr/>
+      </p:sp>
+      <p:sp>
+        <p:nvSpPr>
+          <p:cNvPr id="3" name="Notes Placeholder 2"/>
+          <p:cNvSpPr>
+            <a:spLocks noGrp="1"/>
+          </p:cNvSpPr>
+          <p:nvPr>
+            <p:ph type="body" idx="3" sz="quarter"/>
+          </p:nvPr>
+        </p:nvSpPr>
+        <p:spPr/>
+        <p:txBody>
+          <a:bodyPr/>
+          <a:lstStyle/>
+          <a:p>
+            <a:r>
+              <a:t>Rule 63.7.4 computed as monthly basic pay divided by 22 working days.</a:t>
             </a:r>
           </a:p>
         </p:txBody>
@@ -3950,6 +4092,146 @@
           </a:graphicData>
         </a:graphic>
       </p:graphicFrame>
+    </p:spTree>
+  </p:cSld>
+  <p:clrMapOvr>
+    <a:masterClrMapping/>
+  </p:clrMapOvr>
+</p:sld>
+</file>
+
+<file path=ppt/slides/slide4.xml><?xml version="1.0" encoding="utf-8"?>
+<p:sld xmlns:a="http://schemas.openxmlformats.org/drawingml/2006/main" xmlns:p="http://schemas.openxmlformats.org/presentationml/2006/main" xmlns:r="http://schemas.openxmlformats.org/officeDocument/2006/relationships">
+  <p:cSld>
+    <p:spTree>
+      <p:nvGrpSpPr>
+        <p:cNvPr id="1" name=""/>
+        <p:cNvGrpSpPr/>
+        <p:nvPr/>
+      </p:nvGrpSpPr>
+      <p:grpSpPr/>
+      <p:sp>
+        <p:nvSpPr>
+          <p:cNvPr id="2" name="Title 1"/>
+          <p:cNvSpPr>
+            <a:spLocks noGrp="1"/>
+          </p:cNvSpPr>
+          <p:nvPr>
+            <p:ph type="title"/>
+          </p:nvPr>
+        </p:nvSpPr>
+        <p:spPr/>
+        <p:txBody>
+          <a:bodyPr/>
+          <a:lstStyle/>
+          <a:p>
+            <a:r>
+              <a:t>Leave and Time-Off Entitlements</a:t>
+            </a:r>
+          </a:p>
+        </p:txBody>
+      </p:sp>
+      <p:sp>
+        <p:nvSpPr>
+          <p:cNvPr id="3" name="Content Placeholder 2"/>
+          <p:cNvSpPr>
+            <a:spLocks noGrp="1"/>
+          </p:cNvSpPr>
+          <p:nvPr>
+            <p:ph idx="1"/>
+          </p:nvPr>
+        </p:nvSpPr>
+        <p:spPr/>
+        <p:txBody>
+          <a:bodyPr/>
+          <a:lstStyle/>
+          <a:p>
+            <a:r>
+              <a:t>Full-time employees accrue 24 days of paid annual leave per calendar year (2.0 days/month).</a:t>
+            </a:r>
+          </a:p>
+          <a:p>
+            <a:r>
+              <a:t>Rule 2.1.4 Carry-Forward Restrictions: Maximum 8 unused annual leave days carried forward.</a:t>
+            </a:r>
+          </a:p>
+          <a:p>
+            <a:r>
+              <a:t>Staff members receive 12 days of paid sick leave annually. Absences over 2 days require Form HR-702.</a:t>
+            </a:r>
+          </a:p>
+        </p:txBody>
+      </p:sp>
+    </p:spTree>
+  </p:cSld>
+  <p:clrMapOvr>
+    <a:masterClrMapping/>
+  </p:clrMapOvr>
+</p:sld>
+</file>
+
+<file path=ppt/slides/slide5.xml><?xml version="1.0" encoding="utf-8"?>
+<p:sld xmlns:a="http://schemas.openxmlformats.org/drawingml/2006/main" xmlns:p="http://schemas.openxmlformats.org/presentationml/2006/main" xmlns:r="http://schemas.openxmlformats.org/officeDocument/2006/relationships">
+  <p:cSld>
+    <p:spTree>
+      <p:nvGrpSpPr>
+        <p:cNvPr id="1" name=""/>
+        <p:cNvGrpSpPr/>
+        <p:nvPr/>
+      </p:nvGrpSpPr>
+      <p:grpSpPr/>
+      <p:sp>
+        <p:nvSpPr>
+          <p:cNvPr id="2" name="Title 1"/>
+          <p:cNvSpPr>
+            <a:spLocks noGrp="1"/>
+          </p:cNvSpPr>
+          <p:nvPr>
+            <p:ph type="title"/>
+          </p:nvPr>
+        </p:nvSpPr>
+        <p:spPr/>
+        <p:txBody>
+          <a:bodyPr/>
+          <a:lstStyle/>
+          <a:p>
+            <a:r>
+              <a:t>Separation, Resignation and Exit Terms</a:t>
+            </a:r>
+          </a:p>
+        </p:txBody>
+      </p:sp>
+      <p:sp>
+        <p:nvSpPr>
+          <p:cNvPr id="3" name="Content Placeholder 2"/>
+          <p:cNvSpPr>
+            <a:spLocks noGrp="1"/>
+          </p:cNvSpPr>
+          <p:nvPr>
+            <p:ph idx="1"/>
+          </p:nvPr>
+        </p:nvSpPr>
+        <p:spPr/>
+        <p:txBody>
+          <a:bodyPr/>
+          <a:lstStyle/>
+          <a:p>
+            <a:r>
+              <a:t>Permanent employees must tender formal written notice at least 60 calendar days in advance.</a:t>
+            </a:r>
+          </a:p>
+          <a:p>
+            <a:r>
+              <a:t>Rule 63.7.4 Leave Encashment on Resignation: Accrued annual leave capped at 30 working days encashed.</a:t>
+            </a:r>
+          </a:p>
+          <a:p>
+            <a:r>
+              <a:t>All computing assets, access cards, and proprietary material surrendered on final day.</a:t>
+            </a:r>
+          </a:p>
+        </p:txBody>
+      </p:sp>
     </p:spTree>
   </p:cSld>
   <p:clrMapOvr>

</xml_diff>